<commit_message>
Redesign slides 04 & 13 as intentional breathing compositions
The two zero-text image slides read as random shapes. Rebuild them as
deliberate full-bleed vector scenes that hold on their own (the real
Higgsfield photos remain a drop-in per IMAGES.md):

- 04: flooded city at dusk — skyline silhouette + reflections, a rising
  waterline, and the staff gauge pole submerged past its red flood line.
- 13: the citizen app in a real canal — a phone easing red→green beside
  a gauge pole standing in the water.

Both keep the gauge rail; ripple lines clamped to stay on-canvas.

Co-Authored-By: Claude Opus 4.8 <noreply@anthropic.com>
Claude-Session: https://claude.ai/code/session_01ESxxDNcghtVZxStws4duMy
</commit_message>
<xml_diff>
--- a/pitch-deck/AquaFlow-Pitch-Deck.pptx
+++ b/pitch-deck/AquaFlow-Pitch-Deck.pptx
@@ -872,7 +872,7 @@
           <a:p>
             <a:r>
               <a:rPr lang="en-US" dirty="0"/>
-              <a:t>Zero text. Product in context. Ideal: Higgsfield photo of the gauge pole in a khlong, or a phone in a farmer/resident's hand (images #2/#3 in IMAGES.md).</a:t>
+              <a:t>Zero text. The citizen app in a real canal — the district easing red -&gt; green beside the gauge pole. Optional: replace with the Higgsfield gauge-pole photo (image #2 in IMAGES.md).</a:t>
             </a:r>
             <a:endParaRPr lang="en-US" dirty="0"/>
           </a:p>
@@ -1664,7 +1664,7 @@
           <a:p>
             <a:r>
               <a:rPr lang="en-US" dirty="0"/>
-              <a:t>Zero text. The breath before the pivot. Ideal: full-bleed Higgsfield photo of a flooded Bangkok street (image #1 in IMAGES.md).</a:t>
+              <a:t>Zero text. The breath before the pivot — a flooded city at dusk with the gauge pole submerged past its flood line. Optional: replace with the full-bleed Higgsfield photo (flood.png, image #1 in IMAGES.md).</a:t>
             </a:r>
             <a:endParaRPr lang="en-US" dirty="0"/>
           </a:p>
@@ -9188,12 +9188,299 @@
         </p:nvSpPr>
         <p:spPr>
           <a:xfrm>
-            <a:off x="4825879" y="1460463"/>
-            <a:ext cx="2539937" cy="3936902"/>
+            <a:off x="0" y="4114800"/>
+            <a:ext cx="12191695" cy="2743200"/>
+          </a:xfrm>
+          <a:prstGeom prst="rect">
+            <a:avLst/>
+          </a:prstGeom>
+          <a:solidFill>
+            <a:srgbClr val="1B7A6B">
+              <a:alpha val="74000"/>
+            </a:srgbClr>
+          </a:solidFill>
+          <a:ln/>
+        </p:spPr>
+      </p:sp>
+      <p:sp>
+        <p:nvSpPr>
+          <p:cNvPr id="20" name="Shape 18"/>
+          <p:cNvSpPr/>
+          <p:nvPr/>
+        </p:nvSpPr>
+        <p:spPr>
+          <a:xfrm>
+            <a:off x="0" y="3733810"/>
+            <a:ext cx="12191695" cy="380990"/>
+          </a:xfrm>
+          <a:prstGeom prst="rect">
+            <a:avLst/>
+          </a:prstGeom>
+          <a:solidFill>
+            <a:srgbClr val="1B7A6B">
+              <a:alpha val="38000"/>
+            </a:srgbClr>
+          </a:solidFill>
+          <a:ln/>
+        </p:spPr>
+      </p:sp>
+      <p:sp>
+        <p:nvSpPr>
+          <p:cNvPr id="21" name="Shape 19"/>
+          <p:cNvSpPr/>
+          <p:nvPr/>
+        </p:nvSpPr>
+        <p:spPr>
+          <a:xfrm>
+            <a:off x="1015975" y="4813283"/>
+            <a:ext cx="10159746" cy="0"/>
+          </a:xfrm>
+          <a:prstGeom prst="line">
+            <a:avLst/>
+          </a:prstGeom>
+          <a:noFill/>
+          <a:ln w="9525">
+            <a:solidFill>
+              <a:srgbClr val="EDEEE9">
+                <a:alpha val="26000"/>
+              </a:srgbClr>
+            </a:solidFill>
+            <a:prstDash val="solid"/>
+          </a:ln>
+        </p:spPr>
+      </p:sp>
+      <p:sp>
+        <p:nvSpPr>
+          <p:cNvPr id="22" name="Shape 20"/>
+          <p:cNvSpPr/>
+          <p:nvPr/>
+        </p:nvSpPr>
+        <p:spPr>
+          <a:xfrm>
+            <a:off x="1015975" y="5511765"/>
+            <a:ext cx="10159746" cy="0"/>
+          </a:xfrm>
+          <a:prstGeom prst="line">
+            <a:avLst/>
+          </a:prstGeom>
+          <a:noFill/>
+          <a:ln w="9525">
+            <a:solidFill>
+              <a:srgbClr val="EDEEE9">
+                <a:alpha val="26000"/>
+              </a:srgbClr>
+            </a:solidFill>
+            <a:prstDash val="solid"/>
+          </a:ln>
+        </p:spPr>
+      </p:sp>
+      <p:sp>
+        <p:nvSpPr>
+          <p:cNvPr id="23" name="Shape 21"/>
+          <p:cNvSpPr/>
+          <p:nvPr/>
+        </p:nvSpPr>
+        <p:spPr>
+          <a:xfrm>
+            <a:off x="1015975" y="6210248"/>
+            <a:ext cx="10159746" cy="0"/>
+          </a:xfrm>
+          <a:prstGeom prst="line">
+            <a:avLst/>
+          </a:prstGeom>
+          <a:noFill/>
+          <a:ln w="9525">
+            <a:solidFill>
+              <a:srgbClr val="EDEEE9">
+                <a:alpha val="26000"/>
+              </a:srgbClr>
+            </a:solidFill>
+            <a:prstDash val="solid"/>
+          </a:ln>
+        </p:spPr>
+      </p:sp>
+      <p:sp>
+        <p:nvSpPr>
+          <p:cNvPr id="24" name="Shape 22"/>
+          <p:cNvSpPr/>
+          <p:nvPr/>
+        </p:nvSpPr>
+        <p:spPr>
+          <a:xfrm>
+            <a:off x="2285943" y="2209848"/>
+            <a:ext cx="253994" cy="4076667"/>
+          </a:xfrm>
+          <a:prstGeom prst="rect">
+            <a:avLst/>
+          </a:prstGeom>
+          <a:solidFill>
+            <a:srgbClr val="EDEEE9"/>
+          </a:solidFill>
+          <a:ln w="12700">
+            <a:solidFill>
+              <a:srgbClr val="0A1F20"/>
+            </a:solidFill>
+            <a:prstDash val="solid"/>
+          </a:ln>
+        </p:spPr>
+      </p:sp>
+      <p:sp>
+        <p:nvSpPr>
+          <p:cNvPr id="25" name="Shape 23"/>
+          <p:cNvSpPr/>
+          <p:nvPr/>
+        </p:nvSpPr>
+        <p:spPr>
+          <a:xfrm>
+            <a:off x="2285943" y="2209848"/>
+            <a:ext cx="253994" cy="339722"/>
+          </a:xfrm>
+          <a:prstGeom prst="rect">
+            <a:avLst/>
+          </a:prstGeom>
+          <a:solidFill>
+            <a:srgbClr val="D62828"/>
+          </a:solidFill>
+          <a:ln/>
+        </p:spPr>
+      </p:sp>
+      <p:sp>
+        <p:nvSpPr>
+          <p:cNvPr id="26" name="Shape 24"/>
+          <p:cNvSpPr/>
+          <p:nvPr/>
+        </p:nvSpPr>
+        <p:spPr>
+          <a:xfrm>
+            <a:off x="2285943" y="2889292"/>
+            <a:ext cx="253994" cy="339722"/>
+          </a:xfrm>
+          <a:prstGeom prst="rect">
+            <a:avLst/>
+          </a:prstGeom>
+          <a:solidFill>
+            <a:srgbClr val="D62828"/>
+          </a:solidFill>
+          <a:ln/>
+        </p:spPr>
+      </p:sp>
+      <p:sp>
+        <p:nvSpPr>
+          <p:cNvPr id="27" name="Shape 25"/>
+          <p:cNvSpPr/>
+          <p:nvPr/>
+        </p:nvSpPr>
+        <p:spPr>
+          <a:xfrm>
+            <a:off x="2285943" y="3568737"/>
+            <a:ext cx="253994" cy="339722"/>
+          </a:xfrm>
+          <a:prstGeom prst="rect">
+            <a:avLst/>
+          </a:prstGeom>
+          <a:solidFill>
+            <a:srgbClr val="D62828"/>
+          </a:solidFill>
+          <a:ln/>
+        </p:spPr>
+      </p:sp>
+      <p:sp>
+        <p:nvSpPr>
+          <p:cNvPr id="28" name="Shape 26"/>
+          <p:cNvSpPr/>
+          <p:nvPr/>
+        </p:nvSpPr>
+        <p:spPr>
+          <a:xfrm>
+            <a:off x="2285943" y="4248181"/>
+            <a:ext cx="253994" cy="339722"/>
+          </a:xfrm>
+          <a:prstGeom prst="rect">
+            <a:avLst/>
+          </a:prstGeom>
+          <a:solidFill>
+            <a:srgbClr val="D62828"/>
+          </a:solidFill>
+          <a:ln/>
+        </p:spPr>
+      </p:sp>
+      <p:sp>
+        <p:nvSpPr>
+          <p:cNvPr id="29" name="Shape 27"/>
+          <p:cNvSpPr/>
+          <p:nvPr/>
+        </p:nvSpPr>
+        <p:spPr>
+          <a:xfrm>
+            <a:off x="2285943" y="4927625"/>
+            <a:ext cx="253994" cy="339722"/>
+          </a:xfrm>
+          <a:prstGeom prst="rect">
+            <a:avLst/>
+          </a:prstGeom>
+          <a:solidFill>
+            <a:srgbClr val="D62828"/>
+          </a:solidFill>
+          <a:ln/>
+        </p:spPr>
+      </p:sp>
+      <p:sp>
+        <p:nvSpPr>
+          <p:cNvPr id="30" name="Shape 28"/>
+          <p:cNvSpPr/>
+          <p:nvPr/>
+        </p:nvSpPr>
+        <p:spPr>
+          <a:xfrm>
+            <a:off x="2285943" y="5607070"/>
+            <a:ext cx="253994" cy="339722"/>
+          </a:xfrm>
+          <a:prstGeom prst="rect">
+            <a:avLst/>
+          </a:prstGeom>
+          <a:solidFill>
+            <a:srgbClr val="D62828"/>
+          </a:solidFill>
+          <a:ln/>
+        </p:spPr>
+      </p:sp>
+      <p:sp>
+        <p:nvSpPr>
+          <p:cNvPr id="31" name="Shape 29"/>
+          <p:cNvSpPr/>
+          <p:nvPr/>
+        </p:nvSpPr>
+        <p:spPr>
+          <a:xfrm>
+            <a:off x="1993850" y="4114800"/>
+            <a:ext cx="838179" cy="0"/>
+          </a:xfrm>
+          <a:prstGeom prst="line">
+            <a:avLst/>
+          </a:prstGeom>
+          <a:noFill/>
+          <a:ln w="27940">
+            <a:solidFill>
+              <a:srgbClr val="E3B23C"/>
+            </a:solidFill>
+            <a:prstDash val="solid"/>
+          </a:ln>
+        </p:spPr>
+      </p:sp>
+      <p:sp>
+        <p:nvSpPr>
+          <p:cNvPr id="32" name="Shape 30"/>
+          <p:cNvSpPr/>
+          <p:nvPr/>
+        </p:nvSpPr>
+        <p:spPr>
+          <a:xfrm>
+            <a:off x="6413340" y="952476"/>
+            <a:ext cx="2412940" cy="4317892"/>
           </a:xfrm>
           <a:prstGeom prst="roundRect">
             <a:avLst>
-              <a:gd name="adj" fmla="val 3600"/>
+              <a:gd name="adj" fmla="val 4169"/>
             </a:avLst>
           </a:prstGeom>
           <a:solidFill>
@@ -9206,9 +9493,9 @@
             <a:prstDash val="solid"/>
           </a:ln>
           <a:effectLst>
-            <a:outerShdw sx="100000" sy="100000" kx="0" ky="0" algn="bl" rotWithShape="0" blurRad="177800" dist="76200" dir="5400000">
+            <a:outerShdw sx="100000" sy="100000" kx="0" ky="0" algn="bl" rotWithShape="0" blurRad="203200" dist="88900" dir="5400000">
               <a:srgbClr val="000000">
-                <a:alpha val="40000"/>
+                <a:alpha val="45000"/>
               </a:srgbClr>
             </a:outerShdw>
           </a:effectLst>
@@ -9216,14 +9503,36 @@
       </p:sp>
       <p:sp>
         <p:nvSpPr>
-          <p:cNvPr id="20" name="Shape 18"/>
-          <p:cNvSpPr/>
-          <p:nvPr/>
-        </p:nvSpPr>
-        <p:spPr>
-          <a:xfrm>
-            <a:off x="4978276" y="1650959"/>
-            <a:ext cx="2235144" cy="1650959"/>
+          <p:cNvPr id="33" name="Shape 31"/>
+          <p:cNvSpPr/>
+          <p:nvPr/>
+        </p:nvSpPr>
+        <p:spPr>
+          <a:xfrm>
+            <a:off x="6553036" y="1117572"/>
+            <a:ext cx="2133547" cy="1206470"/>
+          </a:xfrm>
+          <a:prstGeom prst="roundRect">
+            <a:avLst>
+              <a:gd name="adj" fmla="val 6063"/>
+            </a:avLst>
+          </a:prstGeom>
+          <a:solidFill>
+            <a:srgbClr val="1B7A6B"/>
+          </a:solidFill>
+          <a:ln/>
+        </p:spPr>
+      </p:sp>
+      <p:sp>
+        <p:nvSpPr>
+          <p:cNvPr id="34" name="Shape 32"/>
+          <p:cNvSpPr/>
+          <p:nvPr/>
+        </p:nvSpPr>
+        <p:spPr>
+          <a:xfrm>
+            <a:off x="6553036" y="1117572"/>
+            <a:ext cx="597393" cy="1206470"/>
           </a:xfrm>
           <a:prstGeom prst="rect">
             <a:avLst/>
@@ -9236,166 +9545,178 @@
       </p:sp>
       <p:sp>
         <p:nvSpPr>
-          <p:cNvPr id="21" name="Shape 19"/>
-          <p:cNvSpPr/>
-          <p:nvPr/>
-        </p:nvSpPr>
-        <p:spPr>
-          <a:xfrm>
-            <a:off x="4978276" y="2476438"/>
-            <a:ext cx="2235144" cy="825479"/>
-          </a:xfrm>
-          <a:prstGeom prst="rect">
-            <a:avLst/>
+          <p:cNvPr id="35" name="Shape 33"/>
+          <p:cNvSpPr/>
+          <p:nvPr/>
+        </p:nvSpPr>
+        <p:spPr>
+          <a:xfrm>
+            <a:off x="6553036" y="2476438"/>
+            <a:ext cx="2133547" cy="482588"/>
+          </a:xfrm>
+          <a:prstGeom prst="roundRect">
+            <a:avLst>
+              <a:gd name="adj" fmla="val 18948"/>
+            </a:avLst>
           </a:prstGeom>
           <a:solidFill>
-            <a:srgbClr val="1B7A6B"/>
+            <a:srgbClr val="E3E5DE"/>
           </a:solidFill>
           <a:ln/>
         </p:spPr>
       </p:sp>
       <p:sp>
         <p:nvSpPr>
-          <p:cNvPr id="22" name="Shape 20"/>
-          <p:cNvSpPr/>
-          <p:nvPr/>
-        </p:nvSpPr>
-        <p:spPr>
-          <a:xfrm>
-            <a:off x="1904952" y="3809905"/>
-            <a:ext cx="1523962" cy="406390"/>
-          </a:xfrm>
-          <a:prstGeom prst="ellipse">
-            <a:avLst/>
-          </a:prstGeom>
-          <a:ln w="12700">
-            <a:solidFill>
-              <a:srgbClr val="1B7A6B">
-                <a:alpha val="50000"/>
-              </a:srgbClr>
-            </a:solidFill>
-            <a:prstDash val="solid"/>
-          </a:ln>
-        </p:spPr>
-      </p:sp>
-      <p:sp>
-        <p:nvSpPr>
-          <p:cNvPr id="23" name="Shape 21"/>
-          <p:cNvSpPr/>
-          <p:nvPr/>
-        </p:nvSpPr>
-        <p:spPr>
-          <a:xfrm>
-            <a:off x="2349441" y="4190895"/>
-            <a:ext cx="1460463" cy="406390"/>
-          </a:xfrm>
-          <a:prstGeom prst="ellipse">
-            <a:avLst/>
-          </a:prstGeom>
-          <a:ln w="12700">
-            <a:solidFill>
-              <a:srgbClr val="1B7A6B">
-                <a:alpha val="50000"/>
-              </a:srgbClr>
-            </a:solidFill>
-            <a:prstDash val="solid"/>
-          </a:ln>
-        </p:spPr>
-      </p:sp>
-      <p:sp>
-        <p:nvSpPr>
-          <p:cNvPr id="24" name="Shape 22"/>
-          <p:cNvSpPr/>
-          <p:nvPr/>
-        </p:nvSpPr>
-        <p:spPr>
-          <a:xfrm>
-            <a:off x="2793930" y="4571886"/>
-            <a:ext cx="1396965" cy="406390"/>
-          </a:xfrm>
-          <a:prstGeom prst="ellipse">
-            <a:avLst/>
-          </a:prstGeom>
-          <a:ln w="12700">
-            <a:solidFill>
-              <a:srgbClr val="1B7A6B">
-                <a:alpha val="50000"/>
-              </a:srgbClr>
-            </a:solidFill>
-            <a:prstDash val="solid"/>
-          </a:ln>
-        </p:spPr>
-      </p:sp>
-      <p:sp>
-        <p:nvSpPr>
-          <p:cNvPr id="25" name="Shape 23"/>
-          <p:cNvSpPr/>
-          <p:nvPr/>
-        </p:nvSpPr>
-        <p:spPr>
-          <a:xfrm>
-            <a:off x="3238419" y="3809905"/>
-            <a:ext cx="1333467" cy="406390"/>
-          </a:xfrm>
-          <a:prstGeom prst="ellipse">
-            <a:avLst/>
-          </a:prstGeom>
-          <a:ln w="12700">
-            <a:solidFill>
-              <a:srgbClr val="1B7A6B">
-                <a:alpha val="50000"/>
-              </a:srgbClr>
-            </a:solidFill>
-            <a:prstDash val="solid"/>
-          </a:ln>
-        </p:spPr>
-      </p:sp>
-      <p:sp>
-        <p:nvSpPr>
-          <p:cNvPr id="26" name="Shape 24"/>
-          <p:cNvSpPr/>
-          <p:nvPr/>
-        </p:nvSpPr>
-        <p:spPr>
-          <a:xfrm>
-            <a:off x="3682908" y="4190895"/>
-            <a:ext cx="1269968" cy="406390"/>
-          </a:xfrm>
-          <a:prstGeom prst="ellipse">
-            <a:avLst/>
-          </a:prstGeom>
-          <a:ln w="12700">
-            <a:solidFill>
-              <a:srgbClr val="1B7A6B">
-                <a:alpha val="50000"/>
-              </a:srgbClr>
-            </a:solidFill>
-            <a:prstDash val="solid"/>
-          </a:ln>
-        </p:spPr>
-      </p:sp>
-      <p:sp>
-        <p:nvSpPr>
-          <p:cNvPr id="27" name="Shape 25"/>
-          <p:cNvSpPr/>
-          <p:nvPr/>
-        </p:nvSpPr>
-        <p:spPr>
-          <a:xfrm>
-            <a:off x="4127397" y="4571886"/>
-            <a:ext cx="1206470" cy="406390"/>
-          </a:xfrm>
-          <a:prstGeom prst="ellipse">
-            <a:avLst/>
-          </a:prstGeom>
-          <a:ln w="12700">
-            <a:solidFill>
-              <a:srgbClr val="1B7A6B">
-                <a:alpha val="50000"/>
-              </a:srgbClr>
-            </a:solidFill>
-            <a:prstDash val="solid"/>
-          </a:ln>
+          <p:cNvPr id="36" name="Shape 34"/>
+          <p:cNvSpPr/>
+          <p:nvPr/>
+        </p:nvSpPr>
+        <p:spPr>
+          <a:xfrm>
+            <a:off x="6553036" y="2476438"/>
+            <a:ext cx="896090" cy="482588"/>
+          </a:xfrm>
+          <a:prstGeom prst="rect">
+            <a:avLst/>
+          </a:prstGeom>
+          <a:solidFill>
+            <a:srgbClr val="E3B23C">
+              <a:alpha val="70000"/>
+            </a:srgbClr>
+          </a:solidFill>
+          <a:ln/>
+        </p:spPr>
+      </p:sp>
+      <p:sp>
+        <p:nvSpPr>
+          <p:cNvPr id="37" name="Shape 35"/>
+          <p:cNvSpPr/>
+          <p:nvPr/>
+        </p:nvSpPr>
+        <p:spPr>
+          <a:xfrm>
+            <a:off x="6553036" y="3086023"/>
+            <a:ext cx="2133547" cy="482588"/>
+          </a:xfrm>
+          <a:prstGeom prst="roundRect">
+            <a:avLst>
+              <a:gd name="adj" fmla="val 18948"/>
+            </a:avLst>
+          </a:prstGeom>
+          <a:solidFill>
+            <a:srgbClr val="E3E5DE"/>
+          </a:solidFill>
+          <a:ln/>
+        </p:spPr>
+      </p:sp>
+      <p:sp>
+        <p:nvSpPr>
+          <p:cNvPr id="38" name="Shape 36"/>
+          <p:cNvSpPr/>
+          <p:nvPr/>
+        </p:nvSpPr>
+        <p:spPr>
+          <a:xfrm>
+            <a:off x="6553036" y="3086023"/>
+            <a:ext cx="1173451" cy="482588"/>
+          </a:xfrm>
+          <a:prstGeom prst="rect">
+            <a:avLst/>
+          </a:prstGeom>
+          <a:solidFill>
+            <a:srgbClr val="D62828">
+              <a:alpha val="70000"/>
+            </a:srgbClr>
+          </a:solidFill>
+          <a:ln/>
+        </p:spPr>
+      </p:sp>
+      <p:sp>
+        <p:nvSpPr>
+          <p:cNvPr id="39" name="Shape 37"/>
+          <p:cNvSpPr/>
+          <p:nvPr/>
+        </p:nvSpPr>
+        <p:spPr>
+          <a:xfrm>
+            <a:off x="6553036" y="3695608"/>
+            <a:ext cx="2133547" cy="482588"/>
+          </a:xfrm>
+          <a:prstGeom prst="roundRect">
+            <a:avLst>
+              <a:gd name="adj" fmla="val 18948"/>
+            </a:avLst>
+          </a:prstGeom>
+          <a:solidFill>
+            <a:srgbClr val="E3E5DE"/>
+          </a:solidFill>
+          <a:ln/>
+        </p:spPr>
+      </p:sp>
+      <p:sp>
+        <p:nvSpPr>
+          <p:cNvPr id="40" name="Shape 38"/>
+          <p:cNvSpPr/>
+          <p:nvPr/>
+        </p:nvSpPr>
+        <p:spPr>
+          <a:xfrm>
+            <a:off x="6553036" y="3695608"/>
+            <a:ext cx="640064" cy="482588"/>
+          </a:xfrm>
+          <a:prstGeom prst="rect">
+            <a:avLst/>
+          </a:prstGeom>
+          <a:solidFill>
+            <a:srgbClr val="1B7A6B">
+              <a:alpha val="70000"/>
+            </a:srgbClr>
+          </a:solidFill>
+          <a:ln/>
+        </p:spPr>
+      </p:sp>
+      <p:sp>
+        <p:nvSpPr>
+          <p:cNvPr id="41" name="Shape 39"/>
+          <p:cNvSpPr/>
+          <p:nvPr/>
+        </p:nvSpPr>
+        <p:spPr>
+          <a:xfrm>
+            <a:off x="6553036" y="4305192"/>
+            <a:ext cx="2133547" cy="482588"/>
+          </a:xfrm>
+          <a:prstGeom prst="roundRect">
+            <a:avLst>
+              <a:gd name="adj" fmla="val 18948"/>
+            </a:avLst>
+          </a:prstGeom>
+          <a:solidFill>
+            <a:srgbClr val="E3E5DE"/>
+          </a:solidFill>
+          <a:ln/>
+        </p:spPr>
+      </p:sp>
+      <p:sp>
+        <p:nvSpPr>
+          <p:cNvPr id="42" name="Shape 40"/>
+          <p:cNvSpPr/>
+          <p:nvPr/>
+        </p:nvSpPr>
+        <p:spPr>
+          <a:xfrm>
+            <a:off x="6553036" y="4305192"/>
+            <a:ext cx="1024102" cy="482588"/>
+          </a:xfrm>
+          <a:prstGeom prst="rect">
+            <a:avLst/>
+          </a:prstGeom>
+          <a:solidFill>
+            <a:srgbClr val="E3B23C">
+              <a:alpha val="70000"/>
+            </a:srgbClr>
+          </a:solidFill>
+          <a:ln/>
         </p:spPr>
       </p:sp>
     </p:spTree>
@@ -17637,35 +17958,15 @@
         </p:nvSpPr>
         <p:spPr>
           <a:xfrm>
-            <a:off x="3555911" y="761981"/>
-            <a:ext cx="1523962" cy="5334038"/>
+            <a:off x="0" y="2613684"/>
+            <a:ext cx="12191695" cy="952476"/>
           </a:xfrm>
           <a:prstGeom prst="rect">
             <a:avLst/>
           </a:prstGeom>
           <a:solidFill>
-            <a:srgbClr val="13494A"/>
-          </a:solidFill>
-          <a:ln/>
-        </p:spPr>
-      </p:sp>
-      <p:sp>
-        <p:nvSpPr>
-          <p:cNvPr id="20" name="Shape 18"/>
-          <p:cNvSpPr/>
-          <p:nvPr/>
-        </p:nvSpPr>
-        <p:spPr>
-          <a:xfrm>
-            <a:off x="3555911" y="761981"/>
-            <a:ext cx="1523962" cy="381003"/>
-          </a:xfrm>
-          <a:prstGeom prst="rect">
-            <a:avLst/>
-          </a:prstGeom>
-          <a:solidFill>
-            <a:srgbClr val="0F3D3E">
-              <a:alpha val="60000"/>
+            <a:srgbClr val="E3B23C">
+              <a:alpha val="18000"/>
             </a:srgbClr>
           </a:solidFill>
           <a:ln/>
@@ -17673,21 +17974,21 @@
       </p:sp>
       <p:sp>
         <p:nvSpPr>
-          <p:cNvPr id="21" name="Shape 19"/>
-          <p:cNvSpPr/>
-          <p:nvPr/>
-        </p:nvSpPr>
-        <p:spPr>
-          <a:xfrm>
-            <a:off x="3555911" y="1523986"/>
-            <a:ext cx="1523962" cy="381003"/>
+          <p:cNvPr id="20" name="Shape 18"/>
+          <p:cNvSpPr/>
+          <p:nvPr/>
+        </p:nvSpPr>
+        <p:spPr>
+          <a:xfrm>
+            <a:off x="0" y="3121671"/>
+            <a:ext cx="12191695" cy="444489"/>
           </a:xfrm>
           <a:prstGeom prst="rect">
             <a:avLst/>
           </a:prstGeom>
           <a:solidFill>
-            <a:srgbClr val="0F3D3E">
-              <a:alpha val="60000"/>
+            <a:srgbClr val="E3B23C">
+              <a:alpha val="32000"/>
             </a:srgbClr>
           </a:solidFill>
           <a:ln/>
@@ -17695,21 +17996,41 @@
       </p:sp>
       <p:sp>
         <p:nvSpPr>
+          <p:cNvPr id="21" name="Shape 19"/>
+          <p:cNvSpPr/>
+          <p:nvPr/>
+        </p:nvSpPr>
+        <p:spPr>
+          <a:xfrm>
+            <a:off x="933427" y="2613684"/>
+            <a:ext cx="571486" cy="952476"/>
+          </a:xfrm>
+          <a:prstGeom prst="rect">
+            <a:avLst/>
+          </a:prstGeom>
+          <a:solidFill>
+            <a:srgbClr val="0A2E2F"/>
+          </a:solidFill>
+          <a:ln/>
+        </p:spPr>
+      </p:sp>
+      <p:sp>
+        <p:nvSpPr>
           <p:cNvPr id="22" name="Shape 20"/>
           <p:cNvSpPr/>
           <p:nvPr/>
         </p:nvSpPr>
         <p:spPr>
           <a:xfrm>
-            <a:off x="3555911" y="2285992"/>
-            <a:ext cx="1523962" cy="381003"/>
+            <a:off x="933427" y="3566160"/>
+            <a:ext cx="571486" cy="476238"/>
           </a:xfrm>
           <a:prstGeom prst="rect">
             <a:avLst/>
           </a:prstGeom>
           <a:solidFill>
-            <a:srgbClr val="0F3D3E">
-              <a:alpha val="60000"/>
+            <a:srgbClr val="0A2E2F">
+              <a:alpha val="45000"/>
             </a:srgbClr>
           </a:solidFill>
           <a:ln/>
@@ -17723,15 +18044,35 @@
         </p:nvSpPr>
         <p:spPr>
           <a:xfrm>
-            <a:off x="3555911" y="3047997"/>
-            <a:ext cx="1523962" cy="381003"/>
+            <a:off x="1601430" y="2042198"/>
+            <a:ext cx="698483" cy="1523962"/>
           </a:xfrm>
           <a:prstGeom prst="rect">
             <a:avLst/>
           </a:prstGeom>
           <a:solidFill>
-            <a:srgbClr val="0F3D3E">
-              <a:alpha val="60000"/>
+            <a:srgbClr val="0A2E2F"/>
+          </a:solidFill>
+          <a:ln/>
+        </p:spPr>
+      </p:sp>
+      <p:sp>
+        <p:nvSpPr>
+          <p:cNvPr id="24" name="Shape 22"/>
+          <p:cNvSpPr/>
+          <p:nvPr/>
+        </p:nvSpPr>
+        <p:spPr>
+          <a:xfrm>
+            <a:off x="1601430" y="3566160"/>
+            <a:ext cx="698483" cy="761981"/>
+          </a:xfrm>
+          <a:prstGeom prst="rect">
+            <a:avLst/>
+          </a:prstGeom>
+          <a:solidFill>
+            <a:srgbClr val="0A2E2F">
+              <a:alpha val="45000"/>
             </a:srgbClr>
           </a:solidFill>
           <a:ln/>
@@ -17739,21 +18080,41 @@
       </p:sp>
       <p:sp>
         <p:nvSpPr>
-          <p:cNvPr id="24" name="Shape 22"/>
-          <p:cNvSpPr/>
-          <p:nvPr/>
-        </p:nvSpPr>
-        <p:spPr>
-          <a:xfrm>
-            <a:off x="3555911" y="3810003"/>
-            <a:ext cx="1523962" cy="381003"/>
+          <p:cNvPr id="25" name="Shape 23"/>
+          <p:cNvSpPr/>
+          <p:nvPr/>
+        </p:nvSpPr>
+        <p:spPr>
+          <a:xfrm>
+            <a:off x="2550096" y="2423189"/>
+            <a:ext cx="507987" cy="1142971"/>
           </a:xfrm>
           <a:prstGeom prst="rect">
             <a:avLst/>
           </a:prstGeom>
           <a:solidFill>
-            <a:srgbClr val="0F3D3E">
-              <a:alpha val="60000"/>
+            <a:srgbClr val="0A2E2F"/>
+          </a:solidFill>
+          <a:ln/>
+        </p:spPr>
+      </p:sp>
+      <p:sp>
+        <p:nvSpPr>
+          <p:cNvPr id="26" name="Shape 24"/>
+          <p:cNvSpPr/>
+          <p:nvPr/>
+        </p:nvSpPr>
+        <p:spPr>
+          <a:xfrm>
+            <a:off x="2550096" y="3566160"/>
+            <a:ext cx="507987" cy="571486"/>
+          </a:xfrm>
+          <a:prstGeom prst="rect">
+            <a:avLst/>
+          </a:prstGeom>
+          <a:solidFill>
+            <a:srgbClr val="0A2E2F">
+              <a:alpha val="45000"/>
             </a:srgbClr>
           </a:solidFill>
           <a:ln/>
@@ -17761,21 +18122,41 @@
       </p:sp>
       <p:sp>
         <p:nvSpPr>
-          <p:cNvPr id="25" name="Shape 23"/>
-          <p:cNvSpPr/>
-          <p:nvPr/>
-        </p:nvSpPr>
-        <p:spPr>
-          <a:xfrm>
-            <a:off x="3555911" y="4572008"/>
-            <a:ext cx="1523962" cy="381003"/>
+          <p:cNvPr id="27" name="Shape 25"/>
+          <p:cNvSpPr/>
+          <p:nvPr/>
+        </p:nvSpPr>
+        <p:spPr>
+          <a:xfrm>
+            <a:off x="3276518" y="1534211"/>
+            <a:ext cx="761981" cy="2031949"/>
           </a:xfrm>
           <a:prstGeom prst="rect">
             <a:avLst/>
           </a:prstGeom>
           <a:solidFill>
-            <a:srgbClr val="0F3D3E">
-              <a:alpha val="60000"/>
+            <a:srgbClr val="0A2E2F"/>
+          </a:solidFill>
+          <a:ln/>
+        </p:spPr>
+      </p:sp>
+      <p:sp>
+        <p:nvSpPr>
+          <p:cNvPr id="28" name="Shape 26"/>
+          <p:cNvSpPr/>
+          <p:nvPr/>
+        </p:nvSpPr>
+        <p:spPr>
+          <a:xfrm>
+            <a:off x="3276518" y="3566160"/>
+            <a:ext cx="761981" cy="1015975"/>
+          </a:xfrm>
+          <a:prstGeom prst="rect">
+            <a:avLst/>
+          </a:prstGeom>
+          <a:solidFill>
+            <a:srgbClr val="0A2E2F">
+              <a:alpha val="45000"/>
             </a:srgbClr>
           </a:solidFill>
           <a:ln/>
@@ -17783,21 +18164,41 @@
       </p:sp>
       <p:sp>
         <p:nvSpPr>
-          <p:cNvPr id="26" name="Shape 24"/>
-          <p:cNvSpPr/>
-          <p:nvPr/>
-        </p:nvSpPr>
-        <p:spPr>
-          <a:xfrm>
-            <a:off x="3555911" y="5334014"/>
-            <a:ext cx="1523962" cy="381003"/>
+          <p:cNvPr id="29" name="Shape 27"/>
+          <p:cNvSpPr/>
+          <p:nvPr/>
+        </p:nvSpPr>
+        <p:spPr>
+          <a:xfrm>
+            <a:off x="4559186" y="2169195"/>
+            <a:ext cx="634984" cy="1396965"/>
           </a:xfrm>
           <a:prstGeom prst="rect">
             <a:avLst/>
           </a:prstGeom>
           <a:solidFill>
-            <a:srgbClr val="0F3D3E">
-              <a:alpha val="60000"/>
+            <a:srgbClr val="0A2E2F"/>
+          </a:solidFill>
+          <a:ln/>
+        </p:spPr>
+      </p:sp>
+      <p:sp>
+        <p:nvSpPr>
+          <p:cNvPr id="30" name="Shape 28"/>
+          <p:cNvSpPr/>
+          <p:nvPr/>
+        </p:nvSpPr>
+        <p:spPr>
+          <a:xfrm>
+            <a:off x="4559186" y="3566160"/>
+            <a:ext cx="634984" cy="698483"/>
+          </a:xfrm>
+          <a:prstGeom prst="rect">
+            <a:avLst/>
+          </a:prstGeom>
+          <a:solidFill>
+            <a:srgbClr val="0A2E2F">
+              <a:alpha val="45000"/>
             </a:srgbClr>
           </a:solidFill>
           <a:ln/>
@@ -17805,21 +18206,231 @@
       </p:sp>
       <p:sp>
         <p:nvSpPr>
-          <p:cNvPr id="27" name="Shape 25"/>
-          <p:cNvSpPr/>
-          <p:nvPr/>
-        </p:nvSpPr>
-        <p:spPr>
-          <a:xfrm>
-            <a:off x="3555911" y="3002277"/>
-            <a:ext cx="1523962" cy="3093742"/>
+          <p:cNvPr id="31" name="Shape 29"/>
+          <p:cNvSpPr/>
+          <p:nvPr/>
+        </p:nvSpPr>
+        <p:spPr>
+          <a:xfrm>
+            <a:off x="5895193" y="1153220"/>
+            <a:ext cx="888978" cy="2412940"/>
+          </a:xfrm>
+          <a:prstGeom prst="rect">
+            <a:avLst/>
+          </a:prstGeom>
+          <a:solidFill>
+            <a:srgbClr val="0A2E2F"/>
+          </a:solidFill>
+          <a:ln/>
+        </p:spPr>
+      </p:sp>
+      <p:sp>
+        <p:nvSpPr>
+          <p:cNvPr id="32" name="Shape 30"/>
+          <p:cNvSpPr/>
+          <p:nvPr/>
+        </p:nvSpPr>
+        <p:spPr>
+          <a:xfrm>
+            <a:off x="5895193" y="3566160"/>
+            <a:ext cx="888978" cy="1206470"/>
+          </a:xfrm>
+          <a:prstGeom prst="rect">
+            <a:avLst/>
+          </a:prstGeom>
+          <a:solidFill>
+            <a:srgbClr val="0A2E2F">
+              <a:alpha val="45000"/>
+            </a:srgbClr>
+          </a:solidFill>
+          <a:ln/>
+        </p:spPr>
+      </p:sp>
+      <p:sp>
+        <p:nvSpPr>
+          <p:cNvPr id="33" name="Shape 31"/>
+          <p:cNvSpPr/>
+          <p:nvPr/>
+        </p:nvSpPr>
+        <p:spPr>
+          <a:xfrm>
+            <a:off x="7331527" y="1915201"/>
+            <a:ext cx="698483" cy="1650959"/>
+          </a:xfrm>
+          <a:prstGeom prst="rect">
+            <a:avLst/>
+          </a:prstGeom>
+          <a:solidFill>
+            <a:srgbClr val="0A2E2F"/>
+          </a:solidFill>
+          <a:ln/>
+        </p:spPr>
+      </p:sp>
+      <p:sp>
+        <p:nvSpPr>
+          <p:cNvPr id="34" name="Shape 32"/>
+          <p:cNvSpPr/>
+          <p:nvPr/>
+        </p:nvSpPr>
+        <p:spPr>
+          <a:xfrm>
+            <a:off x="7331527" y="3566160"/>
+            <a:ext cx="698483" cy="825479"/>
+          </a:xfrm>
+          <a:prstGeom prst="rect">
+            <a:avLst/>
+          </a:prstGeom>
+          <a:solidFill>
+            <a:srgbClr val="0A2E2F">
+              <a:alpha val="45000"/>
+            </a:srgbClr>
+          </a:solidFill>
+          <a:ln/>
+        </p:spPr>
+      </p:sp>
+      <p:sp>
+        <p:nvSpPr>
+          <p:cNvPr id="35" name="Shape 33"/>
+          <p:cNvSpPr/>
+          <p:nvPr/>
+        </p:nvSpPr>
+        <p:spPr>
+          <a:xfrm>
+            <a:off x="8397030" y="1661208"/>
+            <a:ext cx="761981" cy="1904952"/>
+          </a:xfrm>
+          <a:prstGeom prst="rect">
+            <a:avLst/>
+          </a:prstGeom>
+          <a:solidFill>
+            <a:srgbClr val="0A2E2F"/>
+          </a:solidFill>
+          <a:ln/>
+        </p:spPr>
+      </p:sp>
+      <p:sp>
+        <p:nvSpPr>
+          <p:cNvPr id="36" name="Shape 34"/>
+          <p:cNvSpPr/>
+          <p:nvPr/>
+        </p:nvSpPr>
+        <p:spPr>
+          <a:xfrm>
+            <a:off x="8397030" y="3566160"/>
+            <a:ext cx="761981" cy="952476"/>
+          </a:xfrm>
+          <a:prstGeom prst="rect">
+            <a:avLst/>
+          </a:prstGeom>
+          <a:solidFill>
+            <a:srgbClr val="0A2E2F">
+              <a:alpha val="45000"/>
+            </a:srgbClr>
+          </a:solidFill>
+          <a:ln/>
+        </p:spPr>
+      </p:sp>
+      <p:sp>
+        <p:nvSpPr>
+          <p:cNvPr id="37" name="Shape 35"/>
+          <p:cNvSpPr/>
+          <p:nvPr/>
+        </p:nvSpPr>
+        <p:spPr>
+          <a:xfrm>
+            <a:off x="9711447" y="2296192"/>
+            <a:ext cx="571486" cy="1269968"/>
+          </a:xfrm>
+          <a:prstGeom prst="rect">
+            <a:avLst/>
+          </a:prstGeom>
+          <a:solidFill>
+            <a:srgbClr val="0A2E2F"/>
+          </a:solidFill>
+          <a:ln/>
+        </p:spPr>
+      </p:sp>
+      <p:sp>
+        <p:nvSpPr>
+          <p:cNvPr id="38" name="Shape 36"/>
+          <p:cNvSpPr/>
+          <p:nvPr/>
+        </p:nvSpPr>
+        <p:spPr>
+          <a:xfrm>
+            <a:off x="9711447" y="3566160"/>
+            <a:ext cx="571486" cy="634984"/>
+          </a:xfrm>
+          <a:prstGeom prst="rect">
+            <a:avLst/>
+          </a:prstGeom>
+          <a:solidFill>
+            <a:srgbClr val="0A2E2F">
+              <a:alpha val="45000"/>
+            </a:srgbClr>
+          </a:solidFill>
+          <a:ln/>
+        </p:spPr>
+      </p:sp>
+      <p:sp>
+        <p:nvSpPr>
+          <p:cNvPr id="39" name="Shape 37"/>
+          <p:cNvSpPr/>
+          <p:nvPr/>
+        </p:nvSpPr>
+        <p:spPr>
+          <a:xfrm>
+            <a:off x="10718532" y="2613684"/>
+            <a:ext cx="507987" cy="952476"/>
+          </a:xfrm>
+          <a:prstGeom prst="rect">
+            <a:avLst/>
+          </a:prstGeom>
+          <a:solidFill>
+            <a:srgbClr val="0A2E2F"/>
+          </a:solidFill>
+          <a:ln/>
+        </p:spPr>
+      </p:sp>
+      <p:sp>
+        <p:nvSpPr>
+          <p:cNvPr id="40" name="Shape 38"/>
+          <p:cNvSpPr/>
+          <p:nvPr/>
+        </p:nvSpPr>
+        <p:spPr>
+          <a:xfrm>
+            <a:off x="10718532" y="3566160"/>
+            <a:ext cx="507987" cy="476238"/>
+          </a:xfrm>
+          <a:prstGeom prst="rect">
+            <a:avLst/>
+          </a:prstGeom>
+          <a:solidFill>
+            <a:srgbClr val="0A2E2F">
+              <a:alpha val="45000"/>
+            </a:srgbClr>
+          </a:solidFill>
+          <a:ln/>
+        </p:spPr>
+      </p:sp>
+      <p:sp>
+        <p:nvSpPr>
+          <p:cNvPr id="41" name="Shape 39"/>
+          <p:cNvSpPr/>
+          <p:nvPr/>
+        </p:nvSpPr>
+        <p:spPr>
+          <a:xfrm>
+            <a:off x="0" y="3566160"/>
+            <a:ext cx="12191695" cy="3291840"/>
           </a:xfrm>
           <a:prstGeom prst="rect">
             <a:avLst/>
           </a:prstGeom>
           <a:solidFill>
             <a:srgbClr val="1B7A6B">
-              <a:alpha val="85000"/>
+              <a:alpha val="70000"/>
             </a:srgbClr>
           </a:solidFill>
           <a:ln/>
@@ -17827,14 +18438,234 @@
       </p:sp>
       <p:sp>
         <p:nvSpPr>
-          <p:cNvPr id="28" name="Shape 26"/>
-          <p:cNvSpPr/>
-          <p:nvPr/>
-        </p:nvSpPr>
-        <p:spPr>
-          <a:xfrm>
-            <a:off x="3365416" y="3002277"/>
-            <a:ext cx="1904952" cy="0"/>
+          <p:cNvPr id="42" name="Shape 40"/>
+          <p:cNvSpPr/>
+          <p:nvPr/>
+        </p:nvSpPr>
+        <p:spPr>
+          <a:xfrm>
+            <a:off x="1396965" y="4328141"/>
+            <a:ext cx="9397765" cy="0"/>
+          </a:xfrm>
+          <a:prstGeom prst="line">
+            <a:avLst/>
+          </a:prstGeom>
+          <a:noFill/>
+          <a:ln w="9525">
+            <a:solidFill>
+              <a:srgbClr val="EDEEE9">
+                <a:alpha val="28000"/>
+              </a:srgbClr>
+            </a:solidFill>
+            <a:prstDash val="solid"/>
+          </a:ln>
+        </p:spPr>
+      </p:sp>
+      <p:sp>
+        <p:nvSpPr>
+          <p:cNvPr id="43" name="Shape 41"/>
+          <p:cNvSpPr/>
+          <p:nvPr/>
+        </p:nvSpPr>
+        <p:spPr>
+          <a:xfrm>
+            <a:off x="1396965" y="5090122"/>
+            <a:ext cx="9397765" cy="0"/>
+          </a:xfrm>
+          <a:prstGeom prst="line">
+            <a:avLst/>
+          </a:prstGeom>
+          <a:noFill/>
+          <a:ln w="9525">
+            <a:solidFill>
+              <a:srgbClr val="EDEEE9">
+                <a:alpha val="28000"/>
+              </a:srgbClr>
+            </a:solidFill>
+            <a:prstDash val="solid"/>
+          </a:ln>
+        </p:spPr>
+      </p:sp>
+      <p:sp>
+        <p:nvSpPr>
+          <p:cNvPr id="44" name="Shape 42"/>
+          <p:cNvSpPr/>
+          <p:nvPr/>
+        </p:nvSpPr>
+        <p:spPr>
+          <a:xfrm>
+            <a:off x="1396965" y="5852103"/>
+            <a:ext cx="9397765" cy="0"/>
+          </a:xfrm>
+          <a:prstGeom prst="line">
+            <a:avLst/>
+          </a:prstGeom>
+          <a:noFill/>
+          <a:ln w="9525">
+            <a:solidFill>
+              <a:srgbClr val="EDEEE9">
+                <a:alpha val="28000"/>
+              </a:srgbClr>
+            </a:solidFill>
+            <a:prstDash val="solid"/>
+          </a:ln>
+        </p:spPr>
+      </p:sp>
+      <p:sp>
+        <p:nvSpPr>
+          <p:cNvPr id="45" name="Shape 43"/>
+          <p:cNvSpPr/>
+          <p:nvPr/>
+        </p:nvSpPr>
+        <p:spPr>
+          <a:xfrm>
+            <a:off x="3301917" y="1915201"/>
+            <a:ext cx="292093" cy="4498310"/>
+          </a:xfrm>
+          <a:prstGeom prst="rect">
+            <a:avLst/>
+          </a:prstGeom>
+          <a:solidFill>
+            <a:srgbClr val="EDEEE9"/>
+          </a:solidFill>
+          <a:ln w="12700">
+            <a:solidFill>
+              <a:srgbClr val="0A1F20"/>
+            </a:solidFill>
+            <a:prstDash val="solid"/>
+          </a:ln>
+        </p:spPr>
+      </p:sp>
+      <p:sp>
+        <p:nvSpPr>
+          <p:cNvPr id="46" name="Shape 44"/>
+          <p:cNvSpPr/>
+          <p:nvPr/>
+        </p:nvSpPr>
+        <p:spPr>
+          <a:xfrm>
+            <a:off x="3301917" y="1915201"/>
+            <a:ext cx="292093" cy="374859"/>
+          </a:xfrm>
+          <a:prstGeom prst="rect">
+            <a:avLst/>
+          </a:prstGeom>
+          <a:solidFill>
+            <a:srgbClr val="D62828"/>
+          </a:solidFill>
+          <a:ln/>
+        </p:spPr>
+      </p:sp>
+      <p:sp>
+        <p:nvSpPr>
+          <p:cNvPr id="47" name="Shape 45"/>
+          <p:cNvSpPr/>
+          <p:nvPr/>
+        </p:nvSpPr>
+        <p:spPr>
+          <a:xfrm>
+            <a:off x="3301917" y="2664920"/>
+            <a:ext cx="292093" cy="374859"/>
+          </a:xfrm>
+          <a:prstGeom prst="rect">
+            <a:avLst/>
+          </a:prstGeom>
+          <a:solidFill>
+            <a:srgbClr val="D62828"/>
+          </a:solidFill>
+          <a:ln/>
+        </p:spPr>
+      </p:sp>
+      <p:sp>
+        <p:nvSpPr>
+          <p:cNvPr id="48" name="Shape 46"/>
+          <p:cNvSpPr/>
+          <p:nvPr/>
+        </p:nvSpPr>
+        <p:spPr>
+          <a:xfrm>
+            <a:off x="3301917" y="3414638"/>
+            <a:ext cx="292093" cy="374859"/>
+          </a:xfrm>
+          <a:prstGeom prst="rect">
+            <a:avLst/>
+          </a:prstGeom>
+          <a:solidFill>
+            <a:srgbClr val="D62828"/>
+          </a:solidFill>
+          <a:ln/>
+        </p:spPr>
+      </p:sp>
+      <p:sp>
+        <p:nvSpPr>
+          <p:cNvPr id="49" name="Shape 47"/>
+          <p:cNvSpPr/>
+          <p:nvPr/>
+        </p:nvSpPr>
+        <p:spPr>
+          <a:xfrm>
+            <a:off x="3301917" y="4164356"/>
+            <a:ext cx="292093" cy="374859"/>
+          </a:xfrm>
+          <a:prstGeom prst="rect">
+            <a:avLst/>
+          </a:prstGeom>
+          <a:solidFill>
+            <a:srgbClr val="D62828"/>
+          </a:solidFill>
+          <a:ln/>
+        </p:spPr>
+      </p:sp>
+      <p:sp>
+        <p:nvSpPr>
+          <p:cNvPr id="50" name="Shape 48"/>
+          <p:cNvSpPr/>
+          <p:nvPr/>
+        </p:nvSpPr>
+        <p:spPr>
+          <a:xfrm>
+            <a:off x="3301917" y="4914075"/>
+            <a:ext cx="292093" cy="374859"/>
+          </a:xfrm>
+          <a:prstGeom prst="rect">
+            <a:avLst/>
+          </a:prstGeom>
+          <a:solidFill>
+            <a:srgbClr val="D62828"/>
+          </a:solidFill>
+          <a:ln/>
+        </p:spPr>
+      </p:sp>
+      <p:sp>
+        <p:nvSpPr>
+          <p:cNvPr id="51" name="Shape 49"/>
+          <p:cNvSpPr/>
+          <p:nvPr/>
+        </p:nvSpPr>
+        <p:spPr>
+          <a:xfrm>
+            <a:off x="3301917" y="5663793"/>
+            <a:ext cx="292093" cy="374859"/>
+          </a:xfrm>
+          <a:prstGeom prst="rect">
+            <a:avLst/>
+          </a:prstGeom>
+          <a:solidFill>
+            <a:srgbClr val="D62828"/>
+          </a:solidFill>
+          <a:ln/>
+        </p:spPr>
+      </p:sp>
+      <p:sp>
+        <p:nvSpPr>
+          <p:cNvPr id="52" name="Shape 50"/>
+          <p:cNvSpPr/>
+          <p:nvPr/>
+        </p:nvSpPr>
+        <p:spPr>
+          <a:xfrm>
+            <a:off x="2920927" y="3566160"/>
+            <a:ext cx="1015975" cy="0"/>
           </a:xfrm>
           <a:prstGeom prst="line">
             <a:avLst/>
@@ -17850,14 +18681,14 @@
       </p:sp>
       <p:sp>
         <p:nvSpPr>
-          <p:cNvPr id="29" name="Shape 27"/>
-          <p:cNvSpPr/>
-          <p:nvPr/>
-        </p:nvSpPr>
-        <p:spPr>
-          <a:xfrm>
-            <a:off x="3365416" y="1508746"/>
-            <a:ext cx="1904952" cy="0"/>
+          <p:cNvPr id="53" name="Shape 51"/>
+          <p:cNvSpPr/>
+          <p:nvPr/>
+        </p:nvSpPr>
+        <p:spPr>
+          <a:xfrm>
+            <a:off x="2920927" y="2904829"/>
+            <a:ext cx="1015975" cy="0"/>
           </a:xfrm>
           <a:prstGeom prst="line">
             <a:avLst/>
@@ -17868,131 +18699,6 @@
               <a:srgbClr val="D62828"/>
             </a:solidFill>
             <a:prstDash val="dash"/>
-          </a:ln>
-        </p:spPr>
-      </p:sp>
-      <p:sp>
-        <p:nvSpPr>
-          <p:cNvPr id="30" name="Shape 28"/>
-          <p:cNvSpPr/>
-          <p:nvPr/>
-        </p:nvSpPr>
-        <p:spPr>
-          <a:xfrm>
-            <a:off x="5841854" y="3256271"/>
-            <a:ext cx="1269968" cy="380990"/>
-          </a:xfrm>
-          <a:prstGeom prst="ellipse">
-            <a:avLst/>
-          </a:prstGeom>
-          <a:noFill/>
-          <a:ln w="12700">
-            <a:solidFill>
-              <a:srgbClr val="1B7A6B">
-                <a:alpha val="60000"/>
-              </a:srgbClr>
-            </a:solidFill>
-            <a:prstDash val="solid"/>
-          </a:ln>
-        </p:spPr>
-      </p:sp>
-      <p:sp>
-        <p:nvSpPr>
-          <p:cNvPr id="31" name="Shape 29"/>
-          <p:cNvSpPr/>
-          <p:nvPr/>
-        </p:nvSpPr>
-        <p:spPr>
-          <a:xfrm>
-            <a:off x="6730832" y="3446766"/>
-            <a:ext cx="1142971" cy="342891"/>
-          </a:xfrm>
-          <a:prstGeom prst="ellipse">
-            <a:avLst/>
-          </a:prstGeom>
-          <a:noFill/>
-          <a:ln w="12700">
-            <a:solidFill>
-              <a:srgbClr val="1B7A6B">
-                <a:alpha val="60000"/>
-              </a:srgbClr>
-            </a:solidFill>
-            <a:prstDash val="solid"/>
-          </a:ln>
-        </p:spPr>
-      </p:sp>
-      <p:sp>
-        <p:nvSpPr>
-          <p:cNvPr id="32" name="Shape 30"/>
-          <p:cNvSpPr/>
-          <p:nvPr/>
-        </p:nvSpPr>
-        <p:spPr>
-          <a:xfrm>
-            <a:off x="7619810" y="3637261"/>
-            <a:ext cx="1015975" cy="304792"/>
-          </a:xfrm>
-          <a:prstGeom prst="ellipse">
-            <a:avLst/>
-          </a:prstGeom>
-          <a:noFill/>
-          <a:ln w="12700">
-            <a:solidFill>
-              <a:srgbClr val="1B7A6B">
-                <a:alpha val="60000"/>
-              </a:srgbClr>
-            </a:solidFill>
-            <a:prstDash val="solid"/>
-          </a:ln>
-        </p:spPr>
-      </p:sp>
-      <p:sp>
-        <p:nvSpPr>
-          <p:cNvPr id="33" name="Shape 31"/>
-          <p:cNvSpPr/>
-          <p:nvPr/>
-        </p:nvSpPr>
-        <p:spPr>
-          <a:xfrm>
-            <a:off x="8508787" y="3827756"/>
-            <a:ext cx="888978" cy="266693"/>
-          </a:xfrm>
-          <a:prstGeom prst="ellipse">
-            <a:avLst/>
-          </a:prstGeom>
-          <a:noFill/>
-          <a:ln w="12700">
-            <a:solidFill>
-              <a:srgbClr val="1B7A6B">
-                <a:alpha val="60000"/>
-              </a:srgbClr>
-            </a:solidFill>
-            <a:prstDash val="solid"/>
-          </a:ln>
-        </p:spPr>
-      </p:sp>
-      <p:sp>
-        <p:nvSpPr>
-          <p:cNvPr id="34" name="Shape 32"/>
-          <p:cNvSpPr/>
-          <p:nvPr/>
-        </p:nvSpPr>
-        <p:spPr>
-          <a:xfrm>
-            <a:off x="9397765" y="4018252"/>
-            <a:ext cx="761981" cy="228594"/>
-          </a:xfrm>
-          <a:prstGeom prst="ellipse">
-            <a:avLst/>
-          </a:prstGeom>
-          <a:noFill/>
-          <a:ln w="12700">
-            <a:solidFill>
-              <a:srgbClr val="1B7A6B">
-                <a:alpha val="60000"/>
-              </a:srgbClr>
-            </a:solidFill>
-            <a:prstDash val="solid"/>
           </a:ln>
         </p:spPr>
       </p:sp>

</xml_diff>